<commit_message>
Set Agent Harness for Enterprise workshop title
</commit_message>
<xml_diff>
--- a/slides/Cypher-2026-Agentic-AI.pptx
+++ b/slides/Cypher-2026-Agentic-AI.pptx
@@ -3155,8 +3155,8 @@
         </p:nvSpPr>
         <p:spPr>
           <a:xfrm>
-            <a:off x="548640" y="1508760"/>
-            <a:ext cx="8046720" cy="1508760"/>
+            <a:off x="548640" y="1371600"/>
+            <a:ext cx="8046720" cy="2011680"/>
           </a:xfrm>
           <a:prstGeom prst="rect">
             <a:avLst/>
@@ -3176,8 +3176,8 @@
                 </a:solidFill>
                 <a:latin typeface="Arial"/>
               </a:rPr>
-              <a:t>Agentic AI: Building, Optimizing
-&amp; Operationalizing Agents</a:t>
+              <a:t>Agent Harness for Enterprise:
+Engineering the Runtime for Reliable AI Agents</a:t>
             </a:r>
           </a:p>
         </p:txBody>

</xml_diff>